<commit_message>
Use Prof. Tao's architecture visual; drop asks (HPRC allocation in hand)
</commit_message>
<xml_diff>
--- a/KGCompass_Progress_Short.pptx
+++ b/KGCompass_Progress_Short.pptx
@@ -647,7 +647,7 @@
           <a:lstStyle/>
           <a:p>
             <a:r>
-              <a:t>This is how it all fits together as a system. Bottom: our corpus gets parsed and denoised. Middle: candidate triples pass through the graph judge, only text-supported facts enter the verified KG, which is indexed for retrieval and later pruned. Top: the LLM answers user questions grounded in the KG with citations. The right side is the user loop.</a:t>
+              <a:t>This is the system visual Professor Tao generated and shared in the group, and it captures the architecture really well, so let me walk through it. Bottom layer: heterogeneous data ingestion, our corpus gets parsed and processed. Middle layer: the knowledge graph and retrieval engine, where candidate triples are verified before entering the graph. Top layer: the LLM reasoning core that answers user questions grounded in the KG with traceable citations, and the right side is the conversational interface loop. The image model garbles small text, so I will narrate the labels rather than read them.</a:t>
             </a:r>
           </a:p>
         </p:txBody>
@@ -857,7 +857,7 @@
           <a:lstStyle/>
           <a:p>
             <a:r>
-              <a:t>The plan for the next two months, roughly two-week blocks: full SCIERC reproduction with the released weights, then batch extraction over the whole corpus, then a team labeling sprint to build the gold set which doubles as judge training data, then fine-tune the domain judge, evaluate against the existing QA cases, and start pruning experiments. Three asks from the team: how we split the labeling work, HPRC allocation, and agreement on the relation vocabulary. Happy to adjust the timeline with everyone's availability.</a:t>
+              <a:t>The plan for the next two months, roughly two-week blocks: full SCIERC reproduction with the released weights, then batch extraction over the whole corpus, then a team labeling sprint to build the gold set which doubles as judge training data, then fine-tune the domain judge, evaluate against the existing QA cases, and start pruning experiments. I already have HPRC allocation, so the fine-tuning can start as soon as we have the gold set. The two things to agree on as a team are how we split the gold-set labeling and the relation vocabulary. Happy to adjust the timeline with everyone's availability.</a:t>
             </a:r>
           </a:p>
         </p:txBody>
@@ -4708,7 +4708,7 @@
       </p:sp>
       <p:pic>
         <p:nvPicPr>
-          <p:cNvPr id="3" name="Picture 2" descr="KGCompass_Architecture.png"/>
+          <p:cNvPr id="3" name="Picture 2" descr="generated-image (16).png"/>
           <p:cNvPicPr>
             <a:picLocks noChangeAspect="1"/>
           </p:cNvPicPr>
@@ -4722,8 +4722,8 @@
         </p:blipFill>
         <p:spPr>
           <a:xfrm>
-            <a:off x="960120" y="173736"/>
-            <a:ext cx="10354093" cy="6510528"/>
+            <a:off x="128016" y="137160"/>
+            <a:ext cx="12070080" cy="6583680"/>
           </a:xfrm>
           <a:prstGeom prst="rect">
             <a:avLst/>
@@ -5441,7 +5441,7 @@
                 </a:solidFill>
                 <a:latin typeface="Calibri"/>
               </a:rPr>
-              <a:t>Asks: gold-set labeling split among the team · HPRC allocation · relation vocabulary sign-off</a:t>
+              <a:t>HPRC allocation already in hand - judge fine-tuning can start as soon as the gold set exists.</a:t>
             </a:r>
           </a:p>
         </p:txBody>

</xml_diff>

<commit_message>
Address notes to Prof. Tao; add GitHub link; expand what-was-run detail
</commit_message>
<xml_diff>
--- a/KGCompass_Progress_Short.pptx
+++ b/KGCompass_Progress_Short.pptx
@@ -507,7 +507,7 @@
           <a:lstStyle/>
           <a:p>
             <a:r>
-              <a:t>Hi everyone, quick progress update from my side. First: I read the paper shared in the group thoroughly, end to end including the appendices, and everything today builds on it. It was accepted at EMNLP 2025 main conference and the authors released their code and trained judge weights, which saves us a lot of work.</a:t>
+              <a:t>Thank you Professor Tao for the time. Quick progress update from my side. First: I read the paper you shared in the group thoroughly, end to end including the appendices, and everything I will show today builds on it. It was accepted at EMNLP 2025 main conference and the authors released their code and trained judge weights, which saves us a lot of work. Everything I talk about today is in my GitHub repo, the link is on the slide.</a:t>
             </a:r>
           </a:p>
         </p:txBody>
@@ -647,7 +647,7 @@
           <a:lstStyle/>
           <a:p>
             <a:r>
-              <a:t>This is the system visual Professor Tao generated and shared in the group, and it captures the architecture really well, so let me walk through it. Bottom layer: heterogeneous data ingestion, our corpus gets parsed and processed. Middle layer: the knowledge graph and retrieval engine, where candidate triples are verified before entering the graph. Top layer: the LLM reasoning core that answers user questions grounded in the KG with traceable citations, and the right side is the conversational interface loop. The image model garbles small text, so I will narrate the labels rather than read them.</a:t>
+              <a:t>Professor, this is the visual you generated and shared in the group, and it captures the architecture really well, so let me walk through it. Bottom layer: heterogeneous data ingestion, our corpus gets parsed and processed. Middle layer: the knowledge graph and retrieval engine, where candidate triples are verified before entering the graph. Top layer: the LLM reasoning core that answers user questions grounded in the KG with traceable citations, and the right side is the conversational interface loop. The image model garbles small text, so I will narrate the labels rather than read them.</a:t>
             </a:r>
           </a:p>
         </p:txBody>
@@ -717,7 +717,7 @@
           <a:lstStyle/>
           <a:p>
             <a:r>
-              <a:t>What I actually ran: I have the official repo working locally, reproduced their evaluation on 15 SCIERC abstracts with their own metric code, and the key finding is that filtering raised precision on every single metric but a crude filter also cut recall, which is exactly why the judge has to be a trained model and not rules. I also built a per-triple inspection sheet, 129 triples each with a verdict and the quoted evidence or the exact error, that is directly the triplet accuracy check Professor Tao asked for. And I raised PR number 1 on Sumanth's KG_Bench repo so all of this lives in the team framework.</a:t>
+              <a:t>Let me walk through exactly what I ran. I cloned the authors' official repo, built the Python environment with torch and bert-score, and hit one real bug: their evaluation code hardcodes GPU device cuda:7, so it crashes on any machine without CUDA. I patched it to fall back to Apple silicon or CPU, and that patch is in my repo. Then I ran their full evaluation pipeline on 15 SCIERC test abstracts: an extraction pass produced 129 candidate triples, a strict support-check filter kept 95, and I scored both sets with their own metrics, G-BERTScore, G-BLEU and G-ROUGE. Result: filtering raised precision on every metric, G-BERTScore precision went from 0.90 to 0.94, but recall fell because a crude filter also deletes correct triples. That is the cleanest possible demonstration of why the judge has to be a trained model and not rules. I also built a per-triple inspection sheet, all 129 triples, each with a verdict and either the quoted supporting sentence or the exact error type, which is directly the triplet accuracy check you asked for, Professor. And I raised PR number 1 on Sumanth's KG_Bench repo so all of this lives in the team framework.</a:t>
             </a:r>
           </a:p>
         </p:txBody>
@@ -3979,8 +3979,8 @@
         </p:nvSpPr>
         <p:spPr>
           <a:xfrm>
-            <a:off x="548640" y="5669280"/>
-            <a:ext cx="10972800" cy="640080"/>
+            <a:off x="548640" y="5486400"/>
+            <a:ext cx="10972800" cy="914400"/>
           </a:xfrm>
           <a:prstGeom prst="rect">
             <a:avLst/>
@@ -4006,6 +4006,22 @@
                 <a:latin typeface="Calibri"/>
               </a:rPr>
               <a:t>Srikar Sankranti  ·  TAU Group  ·  Directed Studies, Prof. Jian Tao</a:t>
+            </a:r>
+          </a:p>
+          <a:p>
+            <a:pPr>
+              <a:spcAft>
+                <a:spcPts val="800"/>
+              </a:spcAft>
+            </a:pPr>
+            <a:r>
+              <a:rPr sz="1400" b="1">
+                <a:solidFill>
+                  <a:srgbClr val="0E7C5B"/>
+                </a:solidFill>
+                <a:latin typeface="Calibri"/>
+              </a:rPr>
+              <a:t>All work at: github.com/ssrikar1503/directed-studies-kgcompass</a:t>
             </a:r>
           </a:p>
         </p:txBody>
@@ -4963,13 +4979,13 @@
               </a:spcAft>
             </a:pPr>
             <a:r>
-              <a:rPr sz="1450" b="0">
+              <a:rPr sz="1450" b="1">
                 <a:solidFill>
-                  <a:srgbClr val="1B2530"/>
+                  <a:srgbClr val="3B4CC0"/>
                 </a:solidFill>
                 <a:latin typeface="Calibri"/>
               </a:rPr>
-              <a:t>• Repo: github.com/ssrikar1503/directed-studies-kgcompass (plans, results, inspection CSV).</a:t>
+              <a:t>• Everything is public: github.com/ssrikar1503/directed-studies-kgcompass (plans, results, inspection CSV, this deck).</a:t>
             </a:r>
           </a:p>
           <a:p>

</xml_diff>

<commit_message>
Drop architecture image slide; credit visual in slide 2 note
</commit_message>
<xml_diff>
--- a/KGCompass_Progress_Short.pptx
+++ b/KGCompass_Progress_Short.pptx
@@ -10,7 +10,6 @@
     <p:sldId id="258" r:id="rId9"/>
     <p:sldId id="259" r:id="rId10"/>
     <p:sldId id="260" r:id="rId11"/>
-    <p:sldId id="261" r:id="rId12"/>
   </p:sldIdLst>
   <p:sldSz cx="12191695" cy="6858000" type="screen4x3"/>
   <p:notesSz cx="6858000" cy="9144000"/>
@@ -577,7 +576,7 @@
           <a:lstStyle/>
           <a:p>
             <a:r>
-              <a:t>The paper in one line: do not trust one LLM pass. A big model over-generates candidate triples so recall stays high, then a small fine-tuned 7B judge checks each triple against the source document and filters the wrong ones. The judge is over 90 percent accurate, better than GPT-4o at that narrow task, and training it took only 500 steps on a single 48 GB GPU, so this fits HPRC easily. The table shows it is state of the art on all benchmarks against much bigger systems.</a:t>
+              <a:t>The paper in one line: do not trust one LLM pass. A big model over-generates candidate triples so recall stays high, then a small fine-tuned 7B judge checks each triple against the source document and filters the wrong ones. The judge is over 90 percent accurate, better than GPT-4o at that narrow task, and training it took only 500 steps on a single 48 GB GPU, so this fits HPRC easily. The table shows it is state of the art on all benchmarks against much bigger systems. In the full system, exactly like the architecture visual you shared in the group, this judge sits between candidate triple extraction and the verified knowledge graph that GraphRAG retrieves from.</a:t>
             </a:r>
           </a:p>
         </p:txBody>
@@ -647,7 +646,7 @@
           <a:lstStyle/>
           <a:p>
             <a:r>
-              <a:t>Professor, this is the visual you generated and shared in the group, and it captures the architecture really well, so let me walk through it. Bottom layer: heterogeneous data ingestion, our corpus gets parsed and processed. Middle layer: the knowledge graph and retrieval engine, where candidate triples are verified before entering the graph. Top layer: the LLM reasoning core that answers user questions grounded in the KG with traceable citations, and the right side is the conversational interface loop. The image model garbles small text, so I will narrate the labels rather than read them.</a:t>
+              <a:t>Let me walk through exactly what I ran. I cloned the authors' official repo, built the Python environment with torch and bert-score, and hit one real bug: their evaluation code hardcodes GPU device cuda:7, so it crashes on any machine without CUDA. I patched it to fall back to Apple silicon or CPU, and that patch is in my repo. Then I ran their full evaluation pipeline on 15 SCIERC test abstracts: an extraction pass produced 129 candidate triples, a strict support-check filter kept 95, and I scored both sets with their own metrics, G-BERTScore, G-BLEU and G-ROUGE. Result: filtering raised precision on every metric, G-BERTScore precision went from 0.90 to 0.94, but recall fell because a crude filter also deletes correct triples. That is the cleanest possible demonstration of why the judge has to be a trained model and not rules. I also built a per-triple inspection sheet, all 129 triples, each with a verdict and either the quoted supporting sentence or the exact error type, which is directly the triplet accuracy check you asked for, Professor. And I raised PR number 1 on Sumanth's KG_Bench repo so all of this lives in the team framework.</a:t>
             </a:r>
           </a:p>
         </p:txBody>
@@ -717,7 +716,7 @@
           <a:lstStyle/>
           <a:p>
             <a:r>
-              <a:t>Let me walk through exactly what I ran. I cloned the authors' official repo, built the Python environment with torch and bert-score, and hit one real bug: their evaluation code hardcodes GPU device cuda:7, so it crashes on any machine without CUDA. I patched it to fall back to Apple silicon or CPU, and that patch is in my repo. Then I ran their full evaluation pipeline on 15 SCIERC test abstracts: an extraction pass produced 129 candidate triples, a strict support-check filter kept 95, and I scored both sets with their own metrics, G-BERTScore, G-BLEU and G-ROUGE. Result: filtering raised precision on every metric, G-BERTScore precision went from 0.90 to 0.94, but recall fell because a crude filter also deletes correct triples. That is the cleanest possible demonstration of why the judge has to be a trained model and not rules. I also built a per-triple inspection sheet, all 129 triples, each with a verdict and either the quoted supporting sentence or the exact error type, which is directly the triplet accuracy check you asked for, Professor. And I raised PR number 1 on Sumanth's KG_Bench repo so all of this lives in the team framework.</a:t>
+              <a:t>This week I got access to the animal science Drive folder, thanks Surabhi. About 105 papers plus four QA cases from the existing RAG pipeline, the monensin and metritis question. Those cases are perfect evaluation targets for our KG. I did a first manual extraction from the whole cottonseed review: 35 triples, 31 kept with quoted evidence, 4 rejected. The rejected ones matter most: naive extraction turns 'variable response' into 'increases milk production' and flattens species-conditional facts like gossypol toxicity. That conditional-facts problem is a concrete research angle nobody has published on.</a:t>
             </a:r>
           </a:p>
         </p:txBody>
@@ -743,76 +742,6 @@
 </file>
 
 <file path=ppt/notesSlides/notesSlide5.xml><?xml version="1.0" encoding="utf-8"?>
-<p:notes xmlns:a="http://schemas.openxmlformats.org/drawingml/2006/main" xmlns:p="http://schemas.openxmlformats.org/presentationml/2006/main" xmlns:r="http://schemas.openxmlformats.org/officeDocument/2006/relationships">
-  <p:cSld>
-    <p:spTree>
-      <p:nvGrpSpPr>
-        <p:cNvPr id="1" name=""/>
-        <p:cNvGrpSpPr/>
-        <p:nvPr/>
-      </p:nvGrpSpPr>
-      <p:grpSpPr>
-        <a:xfrm>
-          <a:off x="0" y="0"/>
-          <a:ext cx="0" cy="0"/>
-          <a:chOff x="0" y="0"/>
-          <a:chExt cx="0" cy="0"/>
-        </a:xfrm>
-      </p:grpSpPr>
-      <p:sp>
-        <p:nvSpPr>
-          <p:cNvPr id="2" name="Slide Image Placeholder 1"/>
-          <p:cNvSpPr>
-            <a:spLocks noGrp="1"/>
-          </p:cNvSpPr>
-          <p:nvPr>
-            <p:ph type="sldImg" idx="2"/>
-          </p:nvPr>
-        </p:nvSpPr>
-        <p:spPr/>
-      </p:sp>
-      <p:sp>
-        <p:nvSpPr>
-          <p:cNvPr id="3" name="Notes Placeholder 2"/>
-          <p:cNvSpPr>
-            <a:spLocks noGrp="1"/>
-          </p:cNvSpPr>
-          <p:nvPr>
-            <p:ph type="body" idx="3" sz="quarter"/>
-          </p:nvPr>
-        </p:nvSpPr>
-        <p:spPr/>
-        <p:txBody>
-          <a:bodyPr/>
-          <a:lstStyle/>
-          <a:p>
-            <a:r>
-              <a:t>This week I got access to the animal science Drive folder, thanks Surabhi. About 105 papers plus four QA cases from the existing RAG pipeline, the monensin and metritis question. Those cases are perfect evaluation targets for our KG. I did a first manual extraction from the whole cottonseed review: 35 triples, 31 kept with quoted evidence, 4 rejected. The rejected ones matter most: naive extraction turns 'variable response' into 'increases milk production' and flattens species-conditional facts like gossypol toxicity. That conditional-facts problem is a concrete research angle nobody has published on.</a:t>
-            </a:r>
-          </a:p>
-        </p:txBody>
-      </p:sp>
-      <p:sp>
-        <p:nvSpPr>
-          <p:cNvPr id="4" name="Slide Number Placeholder 3"/>
-          <p:cNvSpPr>
-            <a:spLocks noGrp="1"/>
-          </p:cNvSpPr>
-          <p:nvPr>
-            <p:ph type="sldNum" idx="5" sz="quarter"/>
-          </p:nvPr>
-        </p:nvSpPr>
-        <p:spPr/>
-      </p:sp>
-    </p:spTree>
-  </p:cSld>
-  <p:clrMapOvr>
-    <a:masterClrMapping/>
-  </p:clrMapOvr>
-</p:notes>
-</file>
-
-<file path=ppt/notesSlides/notesSlide6.xml><?xml version="1.0" encoding="utf-8"?>
 <p:notes xmlns:a="http://schemas.openxmlformats.org/drawingml/2006/main" xmlns:p="http://schemas.openxmlformats.org/presentationml/2006/main" xmlns:r="http://schemas.openxmlformats.org/officeDocument/2006/relationships">
   <p:cSld>
     <p:spTree>
@@ -4681,71 +4610,246 @@
       <p:grpSpPr/>
       <p:sp>
         <p:nvSpPr>
-          <p:cNvPr id="2" name="Rectangle 1"/>
-          <p:cNvSpPr/>
+          <p:cNvPr id="2" name="TextBox 1"/>
+          <p:cNvSpPr txBox="1"/>
           <p:nvPr/>
         </p:nvSpPr>
         <p:spPr>
           <a:xfrm>
-            <a:off x="0" y="0"/>
-            <a:ext cx="12191695" cy="6858000"/>
+            <a:off x="548640" y="320040"/>
+            <a:ext cx="10972800" cy="365760"/>
           </a:xfrm>
           <a:prstGeom prst="rect">
             <a:avLst/>
           </a:prstGeom>
-          <a:solidFill>
-            <a:srgbClr val="0B1020"/>
-          </a:solidFill>
-          <a:ln>
-            <a:noFill/>
-          </a:ln>
+          <a:noFill/>
         </p:spPr>
-        <p:style>
-          <a:lnRef idx="1">
-            <a:schemeClr val="accent1"/>
-          </a:lnRef>
-          <a:fillRef idx="3">
-            <a:schemeClr val="accent1"/>
-          </a:fillRef>
-          <a:effectRef idx="2">
-            <a:schemeClr val="accent1"/>
-          </a:effectRef>
-          <a:fontRef idx="minor">
-            <a:schemeClr val="lt1"/>
-          </a:fontRef>
-        </p:style>
-        <p:txBody>
-          <a:bodyPr rtlCol="0" anchor="ctr"/>
-          <a:lstStyle/>
-          <a:p>
-            <a:pPr algn="ctr"/>
-          </a:p>
-        </p:txBody>
-      </p:sp>
-      <p:pic>
-        <p:nvPicPr>
-          <p:cNvPr id="3" name="Picture 2" descr="generated-image (16).png"/>
-          <p:cNvPicPr>
-            <a:picLocks noChangeAspect="1"/>
-          </p:cNvPicPr>
+        <p:txBody>
+          <a:bodyPr wrap="square">
+            <a:spAutoFit/>
+          </a:bodyPr>
+          <a:lstStyle/>
+          <a:p>
+            <a:r>
+              <a:rPr sz="1200" b="1">
+                <a:solidFill>
+                  <a:srgbClr val="3B4CC0"/>
+                </a:solidFill>
+                <a:latin typeface="Consolas"/>
+              </a:rPr>
+              <a:t>HANDS-ON PROGRESS</a:t>
+            </a:r>
+          </a:p>
+        </p:txBody>
+      </p:sp>
+      <p:sp>
+        <p:nvSpPr>
+          <p:cNvPr id="3" name="TextBox 2"/>
+          <p:cNvSpPr txBox="1"/>
           <p:nvPr/>
-        </p:nvPicPr>
-        <p:blipFill>
-          <a:blip r:embed="rId2"/>
-          <a:stretch>
-            <a:fillRect/>
-          </a:stretch>
-        </p:blipFill>
+        </p:nvSpPr>
         <p:spPr>
           <a:xfrm>
-            <a:off x="128016" y="137160"/>
-            <a:ext cx="12070080" cy="6583680"/>
+            <a:off x="548640" y="685800"/>
+            <a:ext cx="11064240" cy="868680"/>
           </a:xfrm>
           <a:prstGeom prst="rect">
             <a:avLst/>
           </a:prstGeom>
+          <a:noFill/>
         </p:spPr>
-      </p:pic>
+        <p:txBody>
+          <a:bodyPr wrap="square">
+            <a:spAutoFit/>
+          </a:bodyPr>
+          <a:lstStyle/>
+          <a:p>
+            <a:r>
+              <a:rPr sz="3000" b="1">
+                <a:solidFill>
+                  <a:srgbClr val="1B2530"/>
+                </a:solidFill>
+                <a:latin typeface="Georgia"/>
+              </a:rPr>
+              <a:t>Reproduced the pipeline, inspected every triple</a:t>
+            </a:r>
+          </a:p>
+        </p:txBody>
+      </p:sp>
+      <p:sp>
+        <p:nvSpPr>
+          <p:cNvPr id="4" name="TextBox 3"/>
+          <p:cNvSpPr txBox="1"/>
+          <p:nvPr/>
+        </p:nvSpPr>
+        <p:spPr>
+          <a:xfrm>
+            <a:off x="548640" y="1783080"/>
+            <a:ext cx="5669280" cy="4480560"/>
+          </a:xfrm>
+          <a:prstGeom prst="rect">
+            <a:avLst/>
+          </a:prstGeom>
+          <a:noFill/>
+        </p:spPr>
+        <p:txBody>
+          <a:bodyPr wrap="square">
+            <a:spAutoFit/>
+          </a:bodyPr>
+          <a:lstStyle/>
+          <a:p>
+            <a:pPr>
+              <a:spcAft>
+                <a:spcPts val="800"/>
+              </a:spcAft>
+            </a:pPr>
+            <a:r>
+              <a:rPr sz="1450" b="0">
+                <a:solidFill>
+                  <a:srgbClr val="1B2530"/>
+                </a:solidFill>
+                <a:latin typeface="Calibri"/>
+              </a:rPr>
+              <a:t>• Official repo running locally (env built, Mac device bug patched).</a:t>
+            </a:r>
+          </a:p>
+          <a:p>
+            <a:pPr>
+              <a:spcAft>
+                <a:spcPts val="800"/>
+              </a:spcAft>
+            </a:pPr>
+            <a:r>
+              <a:rPr sz="1450" b="0">
+                <a:solidFill>
+                  <a:srgbClr val="1B2530"/>
+                </a:solidFill>
+                <a:latin typeface="Calibri"/>
+              </a:rPr>
+              <a:t>• 15 SCIERC abstracts: extraction (129 triples) then strict support filter (95 kept), scored with the paper's own metric code.</a:t>
+            </a:r>
+          </a:p>
+          <a:p>
+            <a:pPr>
+              <a:spcAft>
+                <a:spcPts val="800"/>
+              </a:spcAft>
+            </a:pPr>
+            <a:r>
+              <a:rPr sz="1450" b="0">
+                <a:solidFill>
+                  <a:srgbClr val="1B2530"/>
+                </a:solidFill>
+                <a:latin typeface="Calibri"/>
+              </a:rPr>
+              <a:t>• Filtering raised precision on EVERY metric (G-BS P 0.9006 -&gt; 0.9391); crude filters cut recall - why the judge must be trained.</a:t>
+            </a:r>
+          </a:p>
+          <a:p>
+            <a:pPr>
+              <a:spcAft>
+                <a:spcPts val="800"/>
+              </a:spcAft>
+            </a:pPr>
+            <a:r>
+              <a:rPr sz="1450" b="0">
+                <a:solidFill>
+                  <a:srgbClr val="1B2530"/>
+                </a:solidFill>
+                <a:latin typeface="Calibri"/>
+              </a:rPr>
+              <a:t>• Per-triple inspection CSV: all 129 triples with verdict + quoted evidence or the exact error (inverted relation, dropped negation, vague entity).</a:t>
+            </a:r>
+          </a:p>
+        </p:txBody>
+      </p:sp>
+      <p:sp>
+        <p:nvSpPr>
+          <p:cNvPr id="5" name="TextBox 4"/>
+          <p:cNvSpPr txBox="1"/>
+          <p:nvPr/>
+        </p:nvSpPr>
+        <p:spPr>
+          <a:xfrm>
+            <a:off x="6492240" y="1783080"/>
+            <a:ext cx="5120640" cy="4480560"/>
+          </a:xfrm>
+          <a:prstGeom prst="rect">
+            <a:avLst/>
+          </a:prstGeom>
+          <a:noFill/>
+        </p:spPr>
+        <p:txBody>
+          <a:bodyPr wrap="square">
+            <a:spAutoFit/>
+          </a:bodyPr>
+          <a:lstStyle/>
+          <a:p>
+            <a:pPr>
+              <a:spcAft>
+                <a:spcPts val="800"/>
+              </a:spcAft>
+            </a:pPr>
+            <a:r>
+              <a:rPr sz="1400" b="0">
+                <a:solidFill>
+                  <a:srgbClr val="5E6B7A"/>
+                </a:solidFill>
+                <a:latin typeface="Calibri"/>
+              </a:rPr>
+              <a:t>Shared with the team:</a:t>
+            </a:r>
+          </a:p>
+          <a:p>
+            <a:pPr>
+              <a:spcAft>
+                <a:spcPts val="800"/>
+              </a:spcAft>
+            </a:pPr>
+            <a:r>
+              <a:rPr sz="1450" b="0">
+                <a:solidFill>
+                  <a:srgbClr val="1B2530"/>
+                </a:solidFill>
+                <a:latin typeface="Calibri"/>
+              </a:rPr>
+              <a:t>• PR #1 to KG_Bench_TAU_Group: GraphJudge study mapped into our framework as a construction-time filter stage, with repro results and Mac patch.</a:t>
+            </a:r>
+          </a:p>
+          <a:p>
+            <a:pPr>
+              <a:spcAft>
+                <a:spcPts val="800"/>
+              </a:spcAft>
+            </a:pPr>
+            <a:r>
+              <a:rPr sz="1450" b="1">
+                <a:solidFill>
+                  <a:srgbClr val="3B4CC0"/>
+                </a:solidFill>
+                <a:latin typeface="Calibri"/>
+              </a:rPr>
+              <a:t>• Everything is public: github.com/ssrikar1503/directed-studies-kgcompass (plans, results, inspection CSV, this deck).</a:t>
+            </a:r>
+          </a:p>
+          <a:p>
+            <a:pPr>
+              <a:spcAft>
+                <a:spcPts val="800"/>
+              </a:spcAft>
+            </a:pPr>
+            <a:r>
+              <a:rPr sz="1450" b="1">
+                <a:solidFill>
+                  <a:srgbClr val="0E7C5B"/>
+                </a:solidFill>
+                <a:latin typeface="Calibri"/>
+              </a:rPr>
+              <a:t>• Released judge LoRA weights exist on HuggingFace - we can run judging with zero training first.</a:t>
+            </a:r>
+          </a:p>
+        </p:txBody>
+      </p:sp>
     </p:spTree>
   </p:cSld>
   <p:clrMapOvr>
@@ -4793,7 +4897,7 @@
                 </a:solidFill>
                 <a:latin typeface="Consolas"/>
               </a:rPr>
-              <a:t>HANDS-ON PROGRESS</a:t>
+              <a:t>ANIMAL SCIENCE CORPUS - STARTED THIS WEEK</a:t>
             </a:r>
           </a:p>
         </p:txBody>
@@ -4827,7 +4931,7 @@
                 </a:solidFill>
                 <a:latin typeface="Georgia"/>
               </a:rPr>
-              <a:t>Reproduced the pipeline, inspected every triple</a:t>
+              <a:t>First triples extracted from our own domain</a:t>
             </a:r>
           </a:p>
         </p:txBody>
@@ -4866,7 +4970,7 @@
                 </a:solidFill>
                 <a:latin typeface="Calibri"/>
               </a:rPr>
-              <a:t>• Official repo running locally (env built, Mac device bug patched).</a:t>
+              <a:t>• Drive corpus mapped: ~105 nutrition papers + 4 QA cases from the existing query-expansion RAG pipeline (e.g. monensin vs metritis).</a:t>
             </a:r>
           </a:p>
           <a:p>
@@ -4882,7 +4986,7 @@
                 </a:solidFill>
                 <a:latin typeface="Calibri"/>
               </a:rPr>
-              <a:t>• 15 SCIERC abstracts: extraction (129 triples) then strict support filter (95 kept), scored with the paper's own metric code.</a:t>
+              <a:t>• Those QA cases become our evaluation targets: the KG must answer the same questions, with citations.</a:t>
             </a:r>
           </a:p>
           <a:p>
@@ -4898,23 +5002,7 @@
                 </a:solidFill>
                 <a:latin typeface="Calibri"/>
               </a:rPr>
-              <a:t>• Filtering raised precision on EVERY metric (G-BS P 0.9006 -&gt; 0.9391); crude filters cut recall - why the judge must be trained.</a:t>
-            </a:r>
-          </a:p>
-          <a:p>
-            <a:pPr>
-              <a:spcAft>
-                <a:spcPts val="800"/>
-              </a:spcAft>
-            </a:pPr>
-            <a:r>
-              <a:rPr sz="1450" b="0">
-                <a:solidFill>
-                  <a:srgbClr val="1B2530"/>
-                </a:solidFill>
-                <a:latin typeface="Calibri"/>
-              </a:rPr>
-              <a:t>• Per-triple inspection CSV: all 129 triples with verdict + quoted evidence or the exact error (inverted relation, dropped negation, vague entity).</a:t>
+              <a:t>• First extraction: Arieli 1998 whole-cottonseed review -&gt; 35 triples, 31 kept with quoted evidence, 4 rejected with reasons.</a:t>
             </a:r>
           </a:p>
         </p:txBody>
@@ -4953,7 +5041,7 @@
                 </a:solidFill>
                 <a:latin typeface="Calibri"/>
               </a:rPr>
-              <a:t>Shared with the team:</a:t>
+              <a:t>Rejected examples = the paper's failure modes, live in our domain:</a:t>
             </a:r>
           </a:p>
           <a:p>
@@ -4963,13 +5051,13 @@
               </a:spcAft>
             </a:pPr>
             <a:r>
-              <a:rPr sz="1450" b="0">
+              <a:rPr sz="1350" b="0">
                 <a:solidFill>
-                  <a:srgbClr val="1B2530"/>
+                  <a:srgbClr val="C0392B"/>
                 </a:solidFill>
                 <a:latin typeface="Calibri"/>
               </a:rPr>
-              <a:t>• PR #1 to KG_Bench_TAU_Group: GraphJudge study mapped into our framework as a construction-time filter stage, with repro results and Mac patch.</a:t>
+              <a:t>• 'WCS increases milk production' - source says the response is VARIABLE.</a:t>
             </a:r>
           </a:p>
           <a:p>
@@ -4979,29 +5067,29 @@
               </a:spcAft>
             </a:pPr>
             <a:r>
-              <a:rPr sz="1450" b="1">
+              <a:rPr sz="1350" b="0">
+                <a:solidFill>
+                  <a:srgbClr val="C0392B"/>
+                </a:solidFill>
+                <a:latin typeface="Calibri"/>
+              </a:rPr>
+              <a:t>• 'Gossypol toxic to dairy cows' - source says ruminant females are relatively INSENSITIVE; toxic to monogastrics and males.</a:t>
+            </a:r>
+          </a:p>
+          <a:p>
+            <a:pPr>
+              <a:spcAft>
+                <a:spcPts val="800"/>
+              </a:spcAft>
+            </a:pPr>
+            <a:r>
+              <a:rPr sz="1400" b="1">
                 <a:solidFill>
                   <a:srgbClr val="3B4CC0"/>
                 </a:solidFill>
                 <a:latin typeface="Calibri"/>
               </a:rPr>
-              <a:t>• Everything is public: github.com/ssrikar1503/directed-studies-kgcompass (plans, results, inspection CSV, this deck).</a:t>
-            </a:r>
-          </a:p>
-          <a:p>
-            <a:pPr>
-              <a:spcAft>
-                <a:spcPts val="800"/>
-              </a:spcAft>
-            </a:pPr>
-            <a:r>
-              <a:rPr sz="1450" b="1">
-                <a:solidFill>
-                  <a:srgbClr val="0E7C5B"/>
-                </a:solidFill>
-                <a:latin typeface="Calibri"/>
-              </a:rPr>
-              <a:t>• Released judge LoRA weights exist on HuggingFace - we can run judging with zero training first.</a:t>
+              <a:t>• Species-conditional facts get flattened by naive extraction - a concrete research angle (richer knowledge units).</a:t>
             </a:r>
           </a:p>
         </p:txBody>
@@ -5015,250 +5103,6 @@
 </file>
 
 <file path=ppt/slides/slide5.xml><?xml version="1.0" encoding="utf-8"?>
-<p:sld xmlns:a="http://schemas.openxmlformats.org/drawingml/2006/main" xmlns:p="http://schemas.openxmlformats.org/presentationml/2006/main" xmlns:r="http://schemas.openxmlformats.org/officeDocument/2006/relationships">
-  <p:cSld>
-    <p:spTree>
-      <p:nvGrpSpPr>
-        <p:cNvPr id="1" name=""/>
-        <p:cNvGrpSpPr/>
-        <p:nvPr/>
-      </p:nvGrpSpPr>
-      <p:grpSpPr/>
-      <p:sp>
-        <p:nvSpPr>
-          <p:cNvPr id="2" name="TextBox 1"/>
-          <p:cNvSpPr txBox="1"/>
-          <p:nvPr/>
-        </p:nvSpPr>
-        <p:spPr>
-          <a:xfrm>
-            <a:off x="548640" y="320040"/>
-            <a:ext cx="10972800" cy="365760"/>
-          </a:xfrm>
-          <a:prstGeom prst="rect">
-            <a:avLst/>
-          </a:prstGeom>
-          <a:noFill/>
-        </p:spPr>
-        <p:txBody>
-          <a:bodyPr wrap="square">
-            <a:spAutoFit/>
-          </a:bodyPr>
-          <a:lstStyle/>
-          <a:p>
-            <a:r>
-              <a:rPr sz="1200" b="1">
-                <a:solidFill>
-                  <a:srgbClr val="3B4CC0"/>
-                </a:solidFill>
-                <a:latin typeface="Consolas"/>
-              </a:rPr>
-              <a:t>ANIMAL SCIENCE CORPUS - STARTED THIS WEEK</a:t>
-            </a:r>
-          </a:p>
-        </p:txBody>
-      </p:sp>
-      <p:sp>
-        <p:nvSpPr>
-          <p:cNvPr id="3" name="TextBox 2"/>
-          <p:cNvSpPr txBox="1"/>
-          <p:nvPr/>
-        </p:nvSpPr>
-        <p:spPr>
-          <a:xfrm>
-            <a:off x="548640" y="685800"/>
-            <a:ext cx="11064240" cy="868680"/>
-          </a:xfrm>
-          <a:prstGeom prst="rect">
-            <a:avLst/>
-          </a:prstGeom>
-          <a:noFill/>
-        </p:spPr>
-        <p:txBody>
-          <a:bodyPr wrap="square">
-            <a:spAutoFit/>
-          </a:bodyPr>
-          <a:lstStyle/>
-          <a:p>
-            <a:r>
-              <a:rPr sz="3000" b="1">
-                <a:solidFill>
-                  <a:srgbClr val="1B2530"/>
-                </a:solidFill>
-                <a:latin typeface="Georgia"/>
-              </a:rPr>
-              <a:t>First triples extracted from our own domain</a:t>
-            </a:r>
-          </a:p>
-        </p:txBody>
-      </p:sp>
-      <p:sp>
-        <p:nvSpPr>
-          <p:cNvPr id="4" name="TextBox 3"/>
-          <p:cNvSpPr txBox="1"/>
-          <p:nvPr/>
-        </p:nvSpPr>
-        <p:spPr>
-          <a:xfrm>
-            <a:off x="548640" y="1783080"/>
-            <a:ext cx="5669280" cy="4480560"/>
-          </a:xfrm>
-          <a:prstGeom prst="rect">
-            <a:avLst/>
-          </a:prstGeom>
-          <a:noFill/>
-        </p:spPr>
-        <p:txBody>
-          <a:bodyPr wrap="square">
-            <a:spAutoFit/>
-          </a:bodyPr>
-          <a:lstStyle/>
-          <a:p>
-            <a:pPr>
-              <a:spcAft>
-                <a:spcPts val="800"/>
-              </a:spcAft>
-            </a:pPr>
-            <a:r>
-              <a:rPr sz="1450" b="0">
-                <a:solidFill>
-                  <a:srgbClr val="1B2530"/>
-                </a:solidFill>
-                <a:latin typeface="Calibri"/>
-              </a:rPr>
-              <a:t>• Drive corpus mapped: ~105 nutrition papers + 4 QA cases from the existing query-expansion RAG pipeline (e.g. monensin vs metritis).</a:t>
-            </a:r>
-          </a:p>
-          <a:p>
-            <a:pPr>
-              <a:spcAft>
-                <a:spcPts val="800"/>
-              </a:spcAft>
-            </a:pPr>
-            <a:r>
-              <a:rPr sz="1450" b="0">
-                <a:solidFill>
-                  <a:srgbClr val="1B2530"/>
-                </a:solidFill>
-                <a:latin typeface="Calibri"/>
-              </a:rPr>
-              <a:t>• Those QA cases become our evaluation targets: the KG must answer the same questions, with citations.</a:t>
-            </a:r>
-          </a:p>
-          <a:p>
-            <a:pPr>
-              <a:spcAft>
-                <a:spcPts val="800"/>
-              </a:spcAft>
-            </a:pPr>
-            <a:r>
-              <a:rPr sz="1450" b="0">
-                <a:solidFill>
-                  <a:srgbClr val="1B2530"/>
-                </a:solidFill>
-                <a:latin typeface="Calibri"/>
-              </a:rPr>
-              <a:t>• First extraction: Arieli 1998 whole-cottonseed review -&gt; 35 triples, 31 kept with quoted evidence, 4 rejected with reasons.</a:t>
-            </a:r>
-          </a:p>
-        </p:txBody>
-      </p:sp>
-      <p:sp>
-        <p:nvSpPr>
-          <p:cNvPr id="5" name="TextBox 4"/>
-          <p:cNvSpPr txBox="1"/>
-          <p:nvPr/>
-        </p:nvSpPr>
-        <p:spPr>
-          <a:xfrm>
-            <a:off x="6492240" y="1783080"/>
-            <a:ext cx="5120640" cy="4480560"/>
-          </a:xfrm>
-          <a:prstGeom prst="rect">
-            <a:avLst/>
-          </a:prstGeom>
-          <a:noFill/>
-        </p:spPr>
-        <p:txBody>
-          <a:bodyPr wrap="square">
-            <a:spAutoFit/>
-          </a:bodyPr>
-          <a:lstStyle/>
-          <a:p>
-            <a:pPr>
-              <a:spcAft>
-                <a:spcPts val="800"/>
-              </a:spcAft>
-            </a:pPr>
-            <a:r>
-              <a:rPr sz="1400" b="0">
-                <a:solidFill>
-                  <a:srgbClr val="5E6B7A"/>
-                </a:solidFill>
-                <a:latin typeface="Calibri"/>
-              </a:rPr>
-              <a:t>Rejected examples = the paper's failure modes, live in our domain:</a:t>
-            </a:r>
-          </a:p>
-          <a:p>
-            <a:pPr>
-              <a:spcAft>
-                <a:spcPts val="800"/>
-              </a:spcAft>
-            </a:pPr>
-            <a:r>
-              <a:rPr sz="1350" b="0">
-                <a:solidFill>
-                  <a:srgbClr val="C0392B"/>
-                </a:solidFill>
-                <a:latin typeface="Calibri"/>
-              </a:rPr>
-              <a:t>• 'WCS increases milk production' - source says the response is VARIABLE.</a:t>
-            </a:r>
-          </a:p>
-          <a:p>
-            <a:pPr>
-              <a:spcAft>
-                <a:spcPts val="800"/>
-              </a:spcAft>
-            </a:pPr>
-            <a:r>
-              <a:rPr sz="1350" b="0">
-                <a:solidFill>
-                  <a:srgbClr val="C0392B"/>
-                </a:solidFill>
-                <a:latin typeface="Calibri"/>
-              </a:rPr>
-              <a:t>• 'Gossypol toxic to dairy cows' - source says ruminant females are relatively INSENSITIVE; toxic to monogastrics and males.</a:t>
-            </a:r>
-          </a:p>
-          <a:p>
-            <a:pPr>
-              <a:spcAft>
-                <a:spcPts val="800"/>
-              </a:spcAft>
-            </a:pPr>
-            <a:r>
-              <a:rPr sz="1400" b="1">
-                <a:solidFill>
-                  <a:srgbClr val="3B4CC0"/>
-                </a:solidFill>
-                <a:latin typeface="Calibri"/>
-              </a:rPr>
-              <a:t>• Species-conditional facts get flattened by naive extraction - a concrete research angle (richer knowledge units).</a:t>
-            </a:r>
-          </a:p>
-        </p:txBody>
-      </p:sp>
-    </p:spTree>
-  </p:cSld>
-  <p:clrMapOvr>
-    <a:masterClrMapping/>
-  </p:clrMapOvr>
-</p:sld>
-</file>
-
-<file path=ppt/slides/slide6.xml><?xml version="1.0" encoding="utf-8"?>
 <p:sld xmlns:a="http://schemas.openxmlformats.org/drawingml/2006/main" xmlns:p="http://schemas.openxmlformats.org/presentationml/2006/main" xmlns:r="http://schemas.openxmlformats.org/officeDocument/2006/relationships">
   <p:cSld>
     <p:spTree>

</xml_diff>